<commit_message>
refactor: use matchesFilterPattern(requestUri) from OSGi config instead of hardcoded isApplicablePath
</commit_message>
<xml_diff>
--- a/docs/AEM_Security_Simple_Architecture_Guide.pptx
+++ b/docs/AEM_Security_Simple_Architecture_Guide.pptx
@@ -9436,7 +9436,7 @@
             </a:r>
             <a:br/>
             <a:r>
-              <a:t>isApplicablePath(uri)</a:t>
+              <a:t>matchesFilterPattern(uri)</a:t>
             </a:r>
             <a:br/>
             <a:r>
@@ -10362,7 +10362,7 @@
               </a:defRPr>
             </a:pPr>
             <a:r>
-              <a:t>if (!isApplicablePath(requestUri)) {</a:t>
+              <a:t>if (!matchesFilterPattern(requestUri)) {</a:t>
             </a:r>
           </a:p>
           <a:p>

</xml_diff>